<commit_message>
fix: uploaded repository pictures in pptx
</commit_message>
<xml_diff>
--- a/presentations/Guerrero_5min_SlideDeck.pptx
+++ b/presentations/Guerrero_5min_SlideDeck.pptx
@@ -18,7 +18,7 @@
     <p:sldId id="297" r:id="rId9"/>
     <p:sldId id="299" r:id="rId10"/>
     <p:sldId id="300" r:id="rId11"/>
-    <p:sldId id="301" r:id="rId12"/>
+    <p:sldId id="302" r:id="rId12"/>
   </p:sldIdLst>
   <p:sldSz cx="12192000" cy="6858000"/>
   <p:notesSz cx="6858000" cy="9144000"/>
@@ -117,6 +117,11 @@
       </a:defRPr>
     </a:lvl9pPr>
   </p:defaultTextStyle>
+  <p:extLst>
+    <p:ext uri="{EFAFB233-063F-42B5-8137-9DF3F51BA10A}">
+      <p15:sldGuideLst xmlns:p15="http://schemas.microsoft.com/office/powerpoint/2012/main"/>
+    </p:ext>
+  </p:extLst>
 </p:presentation>
 </file>
 
@@ -10794,10 +10799,7 @@
             <a:avLst/>
           </a:prstGeom>
           <a:solidFill>
-            <a:schemeClr val="tx2">
-              <a:lumMod val="60000"/>
-              <a:lumOff val="40000"/>
-            </a:schemeClr>
+            <a:schemeClr val="bg1"/>
           </a:solidFill>
           <a:ln/>
           <a:effectLst>
@@ -10972,10 +10974,46 @@
           </a:fontRef>
         </p:style>
       </p:cxnSp>
+      <p:pic>
+        <p:nvPicPr>
+          <p:cNvPr id="3" name="Picture 2" descr="Capstone 2: EmporiUm Sales Territory Analysis with Python&#10;&#10;AI-generated content may be incorrect.">
+            <a:extLst>
+              <a:ext uri="{FF2B5EF4-FFF2-40B4-BE49-F238E27FC236}">
+                <a16:creationId xmlns:a16="http://schemas.microsoft.com/office/drawing/2014/main" id="{C4F7DA21-D9A6-B586-1BC9-BCC197122EEE}"/>
+              </a:ext>
+            </a:extLst>
+          </p:cNvPr>
+          <p:cNvPicPr>
+            <a:picLocks noChangeAspect="1"/>
+          </p:cNvPicPr>
+          <p:nvPr/>
+        </p:nvPicPr>
+        <p:blipFill>
+          <a:blip r:embed="rId5">
+            <a:extLst>
+              <a:ext uri="{28A0092B-C50C-407E-A947-70E740481C1C}">
+                <a14:useLocalDpi xmlns:a14="http://schemas.microsoft.com/office/drawing/2010/main" val="0"/>
+              </a:ext>
+            </a:extLst>
+          </a:blip>
+          <a:stretch>
+            <a:fillRect/>
+          </a:stretch>
+        </p:blipFill>
+        <p:spPr>
+          <a:xfrm>
+            <a:off x="6383238" y="1358537"/>
+            <a:ext cx="5278410" cy="4761412"/>
+          </a:xfrm>
+          <a:prstGeom prst="rect">
+            <a:avLst/>
+          </a:prstGeom>
+        </p:spPr>
+      </p:pic>
     </p:spTree>
     <p:extLst>
       <p:ext uri="{BB962C8B-B14F-4D97-AF65-F5344CB8AC3E}">
-        <p14:creationId xmlns:p14="http://schemas.microsoft.com/office/powerpoint/2010/main" val="3970063657"/>
+        <p14:creationId xmlns:p14="http://schemas.microsoft.com/office/powerpoint/2010/main" val="3309688986"/>
       </p:ext>
     </p:extLst>
   </p:cSld>

</xml_diff>